<commit_message>
updated photos in assignment 3and remove comment lines in phase 2
</commit_message>
<xml_diff>
--- a/ppt/FE Assignment Template-3.pptx
+++ b/ppt/FE Assignment Template-3.pptx
@@ -9,6 +9,7 @@
     <p:sldId id="257" r:id="rId3"/>
     <p:sldId id="258" r:id="rId4"/>
     <p:sldId id="259" r:id="rId5"/>
+    <p:sldId id="260" r:id="rId6"/>
   </p:sldIdLst>
   <p:sldSz cx="7569200" cy="10699750"/>
   <p:notesSz cx="7569200" cy="10699750"/>
@@ -175,7 +176,7 @@
           <a:p>
             <a:fld id="{1D8BD707-D9CF-40AE-B4C6-C98DA3205C09}" type="datetimeFigureOut">
               <a:rPr lang="en-US"/>
-              <a:t>3/11/2026</a:t>
+              <a:t>3/12/2026</a:t>
             </a:fld>
             <a:endParaRPr lang="en-US"/>
           </a:p>
@@ -340,7 +341,7 @@
           <a:p>
             <a:fld id="{1D8BD707-D9CF-40AE-B4C6-C98DA3205C09}" type="datetimeFigureOut">
               <a:rPr lang="en-US"/>
-              <a:t>3/11/2026</a:t>
+              <a:t>3/12/2026</a:t>
             </a:fld>
             <a:endParaRPr lang="en-US"/>
           </a:p>
@@ -548,7 +549,7 @@
           <a:p>
             <a:fld id="{1D8BD707-D9CF-40AE-B4C6-C98DA3205C09}" type="datetimeFigureOut">
               <a:rPr lang="en-US"/>
-              <a:t>3/11/2026</a:t>
+              <a:t>3/12/2026</a:t>
             </a:fld>
             <a:endParaRPr lang="en-US"/>
           </a:p>
@@ -690,7 +691,7 @@
           <a:p>
             <a:fld id="{1D8BD707-D9CF-40AE-B4C6-C98DA3205C09}" type="datetimeFigureOut">
               <a:rPr lang="en-US"/>
-              <a:t>3/11/2026</a:t>
+              <a:t>3/12/2026</a:t>
             </a:fld>
             <a:endParaRPr lang="en-US"/>
           </a:p>
@@ -809,7 +810,7 @@
           <a:p>
             <a:fld id="{1D8BD707-D9CF-40AE-B4C6-C98DA3205C09}" type="datetimeFigureOut">
               <a:rPr lang="en-US"/>
-              <a:t>3/11/2026</a:t>
+              <a:t>3/12/2026</a:t>
             </a:fld>
             <a:endParaRPr lang="en-US"/>
           </a:p>
@@ -1022,7 +1023,7 @@
           <a:p>
             <a:fld id="{1D8BD707-D9CF-40AE-B4C6-C98DA3205C09}" type="datetimeFigureOut">
               <a:rPr lang="en-US"/>
-              <a:t>3/11/2026</a:t>
+              <a:t>3/12/2026</a:t>
             </a:fld>
             <a:endParaRPr lang="en-US"/>
           </a:p>
@@ -8597,10 +8598,10 @@
       </p:pic>
       <p:pic>
         <p:nvPicPr>
-          <p:cNvPr id="31" name="Picture 30">
+          <p:cNvPr id="30" name="Picture 29">
             <a:extLst>
               <a:ext uri="{FF2B5EF4-FFF2-40B4-BE49-F238E27FC236}">
-                <a16:creationId xmlns:a16="http://schemas.microsoft.com/office/drawing/2014/main" id="{847A99CC-10FB-4904-9A92-EBC31BB73A2D}"/>
+                <a16:creationId xmlns:a16="http://schemas.microsoft.com/office/drawing/2014/main" id="{22D6C415-CA1F-290C-4700-B535ACB54700}"/>
               </a:ext>
             </a:extLst>
           </p:cNvPr>
@@ -8623,8 +8624,8 @@
         </p:blipFill>
         <p:spPr>
           <a:xfrm>
-            <a:off x="24063" y="7290576"/>
-            <a:ext cx="3404425" cy="3383280"/>
+            <a:off x="59436" y="7346465"/>
+            <a:ext cx="3950589" cy="3353285"/>
           </a:xfrm>
           <a:prstGeom prst="rect">
             <a:avLst/>
@@ -8633,10 +8634,10 @@
       </p:pic>
       <p:pic>
         <p:nvPicPr>
-          <p:cNvPr id="35" name="Picture 34">
+          <p:cNvPr id="33" name="Picture 32">
             <a:extLst>
               <a:ext uri="{FF2B5EF4-FFF2-40B4-BE49-F238E27FC236}">
-                <a16:creationId xmlns:a16="http://schemas.microsoft.com/office/drawing/2014/main" id="{A8F6F22F-55FE-727A-2989-E74CFCEB0ABE}"/>
+                <a16:creationId xmlns:a16="http://schemas.microsoft.com/office/drawing/2014/main" id="{0A9B348F-D6CD-AD19-046C-F640A5F324A7}"/>
               </a:ext>
             </a:extLst>
           </p:cNvPr>
@@ -8659,8 +8660,8 @@
         </p:blipFill>
         <p:spPr>
           <a:xfrm>
-            <a:off x="3192593" y="7233967"/>
-            <a:ext cx="4352544" cy="3485287"/>
+            <a:off x="3409338" y="7360435"/>
+            <a:ext cx="4159862" cy="3339315"/>
           </a:xfrm>
           <a:prstGeom prst="rect">
             <a:avLst/>
@@ -8754,1021 +8755,6 @@
           </a:prstGeom>
         </p:spPr>
       </p:pic>
-      <p:grpSp>
-        <p:nvGrpSpPr>
-          <p:cNvPr id="29" name="object 29">
-            <a:extLst>
-              <a:ext uri="{FF2B5EF4-FFF2-40B4-BE49-F238E27FC236}">
-                <a16:creationId xmlns:a16="http://schemas.microsoft.com/office/drawing/2014/main" id="{DCA6F22D-D77C-5273-0949-BE61BCD13369}"/>
-              </a:ext>
-            </a:extLst>
-          </p:cNvPr>
-          <p:cNvGrpSpPr/>
-          <p:nvPr/>
-        </p:nvGrpSpPr>
-        <p:grpSpPr>
-          <a:xfrm>
-            <a:off x="801369" y="6473824"/>
-            <a:ext cx="6402705" cy="20955"/>
-            <a:chOff x="801369" y="6473824"/>
-            <a:chExt cx="6402705" cy="20955"/>
-          </a:xfrm>
-        </p:grpSpPr>
-        <p:sp>
-          <p:nvSpPr>
-            <p:cNvPr id="30" name="object 30">
-              <a:extLst>
-                <a:ext uri="{FF2B5EF4-FFF2-40B4-BE49-F238E27FC236}">
-                  <a16:creationId xmlns:a16="http://schemas.microsoft.com/office/drawing/2014/main" id="{909C0050-DF1A-8B01-7227-DAB5A6C65112}"/>
-                </a:ext>
-              </a:extLst>
-            </p:cNvPr>
-            <p:cNvSpPr/>
-            <p:nvPr/>
-          </p:nvSpPr>
-          <p:spPr>
-            <a:xfrm>
-              <a:off x="801370" y="6473824"/>
-              <a:ext cx="6400800" cy="19685"/>
-            </a:xfrm>
-            <a:custGeom>
-              <a:avLst/>
-              <a:gdLst/>
-              <a:ahLst/>
-              <a:cxnLst/>
-              <a:rect l="l" t="t" r="r" b="b"/>
-              <a:pathLst>
-                <a:path w="6400800" h="19685">
-                  <a:moveTo>
-                    <a:pt x="6400800" y="0"/>
-                  </a:moveTo>
-                  <a:lnTo>
-                    <a:pt x="0" y="0"/>
-                  </a:lnTo>
-                  <a:lnTo>
-                    <a:pt x="0" y="19685"/>
-                  </a:lnTo>
-                  <a:lnTo>
-                    <a:pt x="6400800" y="19685"/>
-                  </a:lnTo>
-                  <a:lnTo>
-                    <a:pt x="6400800" y="0"/>
-                  </a:lnTo>
-                  <a:close/>
-                </a:path>
-              </a:pathLst>
-            </a:custGeom>
-            <a:solidFill>
-              <a:srgbClr val="9F9F9F"/>
-            </a:solidFill>
-          </p:spPr>
-          <p:txBody>
-            <a:bodyPr wrap="square" lIns="0" tIns="0" rIns="0" bIns="0" rtlCol="0"/>
-            <a:lstStyle/>
-            <a:p>
-              <a:endParaRPr/>
-            </a:p>
-          </p:txBody>
-        </p:sp>
-        <p:sp>
-          <p:nvSpPr>
-            <p:cNvPr id="31" name="object 31">
-              <a:extLst>
-                <a:ext uri="{FF2B5EF4-FFF2-40B4-BE49-F238E27FC236}">
-                  <a16:creationId xmlns:a16="http://schemas.microsoft.com/office/drawing/2014/main" id="{DC14D2F1-540D-A978-0F33-6394DD8544A0}"/>
-                </a:ext>
-              </a:extLst>
-            </p:cNvPr>
-            <p:cNvSpPr/>
-            <p:nvPr/>
-          </p:nvSpPr>
-          <p:spPr>
-            <a:xfrm>
-              <a:off x="7200899" y="6474840"/>
-              <a:ext cx="3175" cy="3175"/>
-            </a:xfrm>
-            <a:custGeom>
-              <a:avLst/>
-              <a:gdLst/>
-              <a:ahLst/>
-              <a:cxnLst/>
-              <a:rect l="l" t="t" r="r" b="b"/>
-              <a:pathLst>
-                <a:path w="3175" h="3175">
-                  <a:moveTo>
-                    <a:pt x="3047" y="0"/>
-                  </a:moveTo>
-                  <a:lnTo>
-                    <a:pt x="0" y="0"/>
-                  </a:lnTo>
-                  <a:lnTo>
-                    <a:pt x="0" y="3047"/>
-                  </a:lnTo>
-                  <a:lnTo>
-                    <a:pt x="3047" y="3047"/>
-                  </a:lnTo>
-                  <a:lnTo>
-                    <a:pt x="3047" y="0"/>
-                  </a:lnTo>
-                  <a:close/>
-                </a:path>
-              </a:pathLst>
-            </a:custGeom>
-            <a:solidFill>
-              <a:srgbClr val="E2E2E2"/>
-            </a:solidFill>
-          </p:spPr>
-          <p:txBody>
-            <a:bodyPr wrap="square" lIns="0" tIns="0" rIns="0" bIns="0" rtlCol="0"/>
-            <a:lstStyle/>
-            <a:p>
-              <a:endParaRPr/>
-            </a:p>
-          </p:txBody>
-        </p:sp>
-        <p:sp>
-          <p:nvSpPr>
-            <p:cNvPr id="32" name="object 32">
-              <a:extLst>
-                <a:ext uri="{FF2B5EF4-FFF2-40B4-BE49-F238E27FC236}">
-                  <a16:creationId xmlns:a16="http://schemas.microsoft.com/office/drawing/2014/main" id="{B4BF53A2-9AD3-61DB-03CB-189AF93F3632}"/>
-                </a:ext>
-              </a:extLst>
-            </p:cNvPr>
-            <p:cNvSpPr/>
-            <p:nvPr/>
-          </p:nvSpPr>
-          <p:spPr>
-            <a:xfrm>
-              <a:off x="801928" y="6474853"/>
-              <a:ext cx="6402070" cy="17145"/>
-            </a:xfrm>
-            <a:custGeom>
-              <a:avLst/>
-              <a:gdLst/>
-              <a:ahLst/>
-              <a:cxnLst/>
-              <a:rect l="l" t="t" r="r" b="b"/>
-              <a:pathLst>
-                <a:path w="6402070" h="17145">
-                  <a:moveTo>
-                    <a:pt x="3048" y="3048"/>
-                  </a:moveTo>
-                  <a:lnTo>
-                    <a:pt x="0" y="3048"/>
-                  </a:lnTo>
-                  <a:lnTo>
-                    <a:pt x="0" y="16751"/>
-                  </a:lnTo>
-                  <a:lnTo>
-                    <a:pt x="3048" y="16751"/>
-                  </a:lnTo>
-                  <a:lnTo>
-                    <a:pt x="3048" y="3048"/>
-                  </a:lnTo>
-                  <a:close/>
-                </a:path>
-                <a:path w="6402070" h="17145">
-                  <a:moveTo>
-                    <a:pt x="6402006" y="0"/>
-                  </a:moveTo>
-                  <a:lnTo>
-                    <a:pt x="6398971" y="0"/>
-                  </a:lnTo>
-                  <a:lnTo>
-                    <a:pt x="6398971" y="3035"/>
-                  </a:lnTo>
-                  <a:lnTo>
-                    <a:pt x="6402006" y="3035"/>
-                  </a:lnTo>
-                  <a:lnTo>
-                    <a:pt x="6402006" y="0"/>
-                  </a:lnTo>
-                  <a:close/>
-                </a:path>
-              </a:pathLst>
-            </a:custGeom>
-            <a:solidFill>
-              <a:srgbClr val="9F9F9F"/>
-            </a:solidFill>
-          </p:spPr>
-          <p:txBody>
-            <a:bodyPr wrap="square" lIns="0" tIns="0" rIns="0" bIns="0" rtlCol="0"/>
-            <a:lstStyle/>
-            <a:p>
-              <a:endParaRPr/>
-            </a:p>
-          </p:txBody>
-        </p:sp>
-        <p:sp>
-          <p:nvSpPr>
-            <p:cNvPr id="33" name="object 33">
-              <a:extLst>
-                <a:ext uri="{FF2B5EF4-FFF2-40B4-BE49-F238E27FC236}">
-                  <a16:creationId xmlns:a16="http://schemas.microsoft.com/office/drawing/2014/main" id="{0D499D1B-EA34-984D-D9F3-F881955FF615}"/>
-                </a:ext>
-              </a:extLst>
-            </p:cNvPr>
-            <p:cNvSpPr/>
-            <p:nvPr/>
-          </p:nvSpPr>
-          <p:spPr>
-            <a:xfrm>
-              <a:off x="7200899" y="6477888"/>
-              <a:ext cx="3175" cy="13970"/>
-            </a:xfrm>
-            <a:custGeom>
-              <a:avLst/>
-              <a:gdLst/>
-              <a:ahLst/>
-              <a:cxnLst/>
-              <a:rect l="l" t="t" r="r" b="b"/>
-              <a:pathLst>
-                <a:path w="3175" h="13970">
-                  <a:moveTo>
-                    <a:pt x="3047" y="0"/>
-                  </a:moveTo>
-                  <a:lnTo>
-                    <a:pt x="0" y="0"/>
-                  </a:lnTo>
-                  <a:lnTo>
-                    <a:pt x="0" y="13715"/>
-                  </a:lnTo>
-                  <a:lnTo>
-                    <a:pt x="3047" y="13715"/>
-                  </a:lnTo>
-                  <a:lnTo>
-                    <a:pt x="3047" y="0"/>
-                  </a:lnTo>
-                  <a:close/>
-                </a:path>
-              </a:pathLst>
-            </a:custGeom>
-            <a:solidFill>
-              <a:srgbClr val="E2E2E2"/>
-            </a:solidFill>
-          </p:spPr>
-          <p:txBody>
-            <a:bodyPr wrap="square" lIns="0" tIns="0" rIns="0" bIns="0" rtlCol="0"/>
-            <a:lstStyle/>
-            <a:p>
-              <a:endParaRPr/>
-            </a:p>
-          </p:txBody>
-        </p:sp>
-        <p:sp>
-          <p:nvSpPr>
-            <p:cNvPr id="34" name="object 34">
-              <a:extLst>
-                <a:ext uri="{FF2B5EF4-FFF2-40B4-BE49-F238E27FC236}">
-                  <a16:creationId xmlns:a16="http://schemas.microsoft.com/office/drawing/2014/main" id="{FC1370C6-0E18-BEC3-6A9E-25A57A75A21B}"/>
-                </a:ext>
-              </a:extLst>
-            </p:cNvPr>
-            <p:cNvSpPr/>
-            <p:nvPr/>
-          </p:nvSpPr>
-          <p:spPr>
-            <a:xfrm>
-              <a:off x="801928" y="6491604"/>
-              <a:ext cx="3175" cy="3175"/>
-            </a:xfrm>
-            <a:custGeom>
-              <a:avLst/>
-              <a:gdLst/>
-              <a:ahLst/>
-              <a:cxnLst/>
-              <a:rect l="l" t="t" r="r" b="b"/>
-              <a:pathLst>
-                <a:path w="3175" h="3175">
-                  <a:moveTo>
-                    <a:pt x="3048" y="0"/>
-                  </a:moveTo>
-                  <a:lnTo>
-                    <a:pt x="0" y="0"/>
-                  </a:lnTo>
-                  <a:lnTo>
-                    <a:pt x="0" y="3047"/>
-                  </a:lnTo>
-                  <a:lnTo>
-                    <a:pt x="3048" y="3047"/>
-                  </a:lnTo>
-                  <a:lnTo>
-                    <a:pt x="3048" y="0"/>
-                  </a:lnTo>
-                  <a:close/>
-                </a:path>
-              </a:pathLst>
-            </a:custGeom>
-            <a:solidFill>
-              <a:srgbClr val="9F9F9F"/>
-            </a:solidFill>
-          </p:spPr>
-          <p:txBody>
-            <a:bodyPr wrap="square" lIns="0" tIns="0" rIns="0" bIns="0" rtlCol="0"/>
-            <a:lstStyle/>
-            <a:p>
-              <a:endParaRPr/>
-            </a:p>
-          </p:txBody>
-        </p:sp>
-        <p:sp>
-          <p:nvSpPr>
-            <p:cNvPr id="35" name="object 35">
-              <a:extLst>
-                <a:ext uri="{FF2B5EF4-FFF2-40B4-BE49-F238E27FC236}">
-                  <a16:creationId xmlns:a16="http://schemas.microsoft.com/office/drawing/2014/main" id="{BB927645-12B5-283F-73E0-0B56C6709D9C}"/>
-                </a:ext>
-              </a:extLst>
-            </p:cNvPr>
-            <p:cNvSpPr/>
-            <p:nvPr/>
-          </p:nvSpPr>
-          <p:spPr>
-            <a:xfrm>
-              <a:off x="801928" y="6491617"/>
-              <a:ext cx="6402070" cy="3175"/>
-            </a:xfrm>
-            <a:custGeom>
-              <a:avLst/>
-              <a:gdLst/>
-              <a:ahLst/>
-              <a:cxnLst/>
-              <a:rect l="l" t="t" r="r" b="b"/>
-              <a:pathLst>
-                <a:path w="6402070" h="3175">
-                  <a:moveTo>
-                    <a:pt x="6402006" y="0"/>
-                  </a:moveTo>
-                  <a:lnTo>
-                    <a:pt x="6399022" y="0"/>
-                  </a:lnTo>
-                  <a:lnTo>
-                    <a:pt x="3048" y="0"/>
-                  </a:lnTo>
-                  <a:lnTo>
-                    <a:pt x="0" y="0"/>
-                  </a:lnTo>
-                  <a:lnTo>
-                    <a:pt x="0" y="3035"/>
-                  </a:lnTo>
-                  <a:lnTo>
-                    <a:pt x="3048" y="3035"/>
-                  </a:lnTo>
-                  <a:lnTo>
-                    <a:pt x="6398971" y="3035"/>
-                  </a:lnTo>
-                  <a:lnTo>
-                    <a:pt x="6402006" y="3035"/>
-                  </a:lnTo>
-                  <a:lnTo>
-                    <a:pt x="6402006" y="0"/>
-                  </a:lnTo>
-                  <a:close/>
-                </a:path>
-              </a:pathLst>
-            </a:custGeom>
-            <a:solidFill>
-              <a:srgbClr val="E2E2E2"/>
-            </a:solidFill>
-          </p:spPr>
-          <p:txBody>
-            <a:bodyPr wrap="square" lIns="0" tIns="0" rIns="0" bIns="0" rtlCol="0"/>
-            <a:lstStyle/>
-            <a:p>
-              <a:endParaRPr/>
-            </a:p>
-          </p:txBody>
-        </p:sp>
-      </p:grpSp>
-      <p:sp>
-        <p:nvSpPr>
-          <p:cNvPr id="36" name="object 36">
-            <a:extLst>
-              <a:ext uri="{FF2B5EF4-FFF2-40B4-BE49-F238E27FC236}">
-                <a16:creationId xmlns:a16="http://schemas.microsoft.com/office/drawing/2014/main" id="{C6F8C91A-DE82-E27A-9F35-97C92F7E9BB8}"/>
-              </a:ext>
-            </a:extLst>
-          </p:cNvPr>
-          <p:cNvSpPr txBox="1"/>
-          <p:nvPr/>
-        </p:nvSpPr>
-        <p:spPr>
-          <a:xfrm>
-            <a:off x="789228" y="6661784"/>
-            <a:ext cx="5911850" cy="1690847"/>
-          </a:xfrm>
-          <a:prstGeom prst="rect">
-            <a:avLst/>
-          </a:prstGeom>
-        </p:spPr>
-        <p:txBody>
-          <a:bodyPr vert="horz" wrap="square" lIns="0" tIns="13335" rIns="0" bIns="0" rtlCol="0">
-            <a:spAutoFit/>
-          </a:bodyPr>
-          <a:lstStyle/>
-          <a:p>
-            <a:pPr marL="12700">
-              <a:lnSpc>
-                <a:spcPct val="100000"/>
-              </a:lnSpc>
-              <a:spcBef>
-                <a:spcPts val="105"/>
-              </a:spcBef>
-            </a:pPr>
-            <a:r>
-              <a:rPr sz="1400" b="1" dirty="0">
-                <a:solidFill>
-                  <a:srgbClr val="3B78D7"/>
-                </a:solidFill>
-                <a:latin typeface="Times New Roman"/>
-                <a:cs typeface="Times New Roman"/>
-              </a:rPr>
-              <a:t>7.Learning</a:t>
-            </a:r>
-            <a:r>
-              <a:rPr sz="1400" b="1" spc="-45" dirty="0">
-                <a:solidFill>
-                  <a:srgbClr val="3B78D7"/>
-                </a:solidFill>
-                <a:latin typeface="Times New Roman"/>
-                <a:cs typeface="Times New Roman"/>
-              </a:rPr>
-              <a:t> </a:t>
-            </a:r>
-            <a:r>
-              <a:rPr sz="1400" b="1" spc="-10" dirty="0">
-                <a:solidFill>
-                  <a:srgbClr val="3B78D7"/>
-                </a:solidFill>
-                <a:latin typeface="Times New Roman"/>
-                <a:cs typeface="Times New Roman"/>
-              </a:rPr>
-              <a:t>Outcome:</a:t>
-            </a:r>
-            <a:endParaRPr sz="1400" dirty="0">
-              <a:latin typeface="Times New Roman"/>
-              <a:cs typeface="Times New Roman"/>
-            </a:endParaRPr>
-          </a:p>
-          <a:p>
-            <a:pPr marL="109855" marR="5080">
-              <a:lnSpc>
-                <a:spcPts val="1380"/>
-              </a:lnSpc>
-              <a:spcBef>
-                <a:spcPts val="1025"/>
-              </a:spcBef>
-            </a:pPr>
-            <a:r>
-              <a:rPr lang="en-US" sz="1300" b="1" dirty="0">
-                <a:latin typeface="Times New Roman"/>
-                <a:cs typeface="Times New Roman"/>
-              </a:rPr>
-              <a:t>Interactivity</a:t>
-            </a:r>
-            <a:r>
-              <a:rPr lang="en-US" sz="1300" dirty="0">
-                <a:latin typeface="Times New Roman"/>
-                <a:cs typeface="Times New Roman"/>
-              </a:rPr>
-              <a:t>: I learned how to move beyond static styling and create a functional web application using JavaScript.</a:t>
-            </a:r>
-          </a:p>
-          <a:p>
-            <a:pPr marL="109855" marR="5080">
-              <a:lnSpc>
-                <a:spcPts val="1380"/>
-              </a:lnSpc>
-              <a:spcBef>
-                <a:spcPts val="1025"/>
-              </a:spcBef>
-            </a:pPr>
-            <a:r>
-              <a:rPr lang="en-US" sz="1300" b="1" dirty="0">
-                <a:latin typeface="Times New Roman"/>
-                <a:cs typeface="Times New Roman"/>
-              </a:rPr>
-              <a:t>Data Integrity</a:t>
-            </a:r>
-            <a:r>
-              <a:rPr lang="en-US" sz="1300" dirty="0">
-                <a:latin typeface="Times New Roman"/>
-                <a:cs typeface="Times New Roman"/>
-              </a:rPr>
-              <a:t>: I understood how to enforce rules on user input to ensure the database (or table) only receives correctly formatted information.</a:t>
-            </a:r>
-          </a:p>
-          <a:p>
-            <a:pPr marL="109855" marR="5080">
-              <a:lnSpc>
-                <a:spcPts val="1380"/>
-              </a:lnSpc>
-              <a:spcBef>
-                <a:spcPts val="1025"/>
-              </a:spcBef>
-            </a:pPr>
-            <a:r>
-              <a:rPr lang="en-US" sz="1300" b="1" dirty="0">
-                <a:latin typeface="Times New Roman"/>
-                <a:cs typeface="Times New Roman"/>
-              </a:rPr>
-              <a:t>DOM Skills</a:t>
-            </a:r>
-            <a:r>
-              <a:rPr lang="en-US" sz="1300" dirty="0">
-                <a:latin typeface="Times New Roman"/>
-                <a:cs typeface="Times New Roman"/>
-              </a:rPr>
-              <a:t>: I gained confidence in manipulating the Document Object Model to change page content dynamically without a server.</a:t>
-            </a:r>
-            <a:endParaRPr sz="1300" dirty="0">
-              <a:latin typeface="Times New Roman"/>
-              <a:cs typeface="Times New Roman"/>
-            </a:endParaRPr>
-          </a:p>
-        </p:txBody>
-      </p:sp>
-      <p:grpSp>
-        <p:nvGrpSpPr>
-          <p:cNvPr id="37" name="object 37">
-            <a:extLst>
-              <a:ext uri="{FF2B5EF4-FFF2-40B4-BE49-F238E27FC236}">
-                <a16:creationId xmlns:a16="http://schemas.microsoft.com/office/drawing/2014/main" id="{F73209A1-B658-BB94-8DE9-97B9BAAF9651}"/>
-              </a:ext>
-            </a:extLst>
-          </p:cNvPr>
-          <p:cNvGrpSpPr/>
-          <p:nvPr/>
-        </p:nvGrpSpPr>
-        <p:grpSpPr>
-          <a:xfrm>
-            <a:off x="789228" y="8778875"/>
-            <a:ext cx="6402705" cy="20955"/>
-            <a:chOff x="801369" y="7811769"/>
-            <a:chExt cx="6402705" cy="20955"/>
-          </a:xfrm>
-        </p:grpSpPr>
-        <p:sp>
-          <p:nvSpPr>
-            <p:cNvPr id="38" name="object 38">
-              <a:extLst>
-                <a:ext uri="{FF2B5EF4-FFF2-40B4-BE49-F238E27FC236}">
-                  <a16:creationId xmlns:a16="http://schemas.microsoft.com/office/drawing/2014/main" id="{030DE98A-A045-F160-2CDB-9FED1A919A79}"/>
-                </a:ext>
-              </a:extLst>
-            </p:cNvPr>
-            <p:cNvSpPr/>
-            <p:nvPr/>
-          </p:nvSpPr>
-          <p:spPr>
-            <a:xfrm>
-              <a:off x="801370" y="7811769"/>
-              <a:ext cx="6400800" cy="20320"/>
-            </a:xfrm>
-            <a:custGeom>
-              <a:avLst/>
-              <a:gdLst/>
-              <a:ahLst/>
-              <a:cxnLst/>
-              <a:rect l="l" t="t" r="r" b="b"/>
-              <a:pathLst>
-                <a:path w="6400800" h="20320">
-                  <a:moveTo>
-                    <a:pt x="6400800" y="0"/>
-                  </a:moveTo>
-                  <a:lnTo>
-                    <a:pt x="0" y="0"/>
-                  </a:lnTo>
-                  <a:lnTo>
-                    <a:pt x="0" y="20320"/>
-                  </a:lnTo>
-                  <a:lnTo>
-                    <a:pt x="6400800" y="20320"/>
-                  </a:lnTo>
-                  <a:lnTo>
-                    <a:pt x="6400800" y="0"/>
-                  </a:lnTo>
-                  <a:close/>
-                </a:path>
-              </a:pathLst>
-            </a:custGeom>
-            <a:solidFill>
-              <a:srgbClr val="9F9F9F"/>
-            </a:solidFill>
-          </p:spPr>
-          <p:txBody>
-            <a:bodyPr wrap="square" lIns="0" tIns="0" rIns="0" bIns="0" rtlCol="0"/>
-            <a:lstStyle/>
-            <a:p>
-              <a:endParaRPr/>
-            </a:p>
-          </p:txBody>
-        </p:sp>
-        <p:sp>
-          <p:nvSpPr>
-            <p:cNvPr id="39" name="object 39">
-              <a:extLst>
-                <a:ext uri="{FF2B5EF4-FFF2-40B4-BE49-F238E27FC236}">
-                  <a16:creationId xmlns:a16="http://schemas.microsoft.com/office/drawing/2014/main" id="{1540B0B7-F66A-09A9-CEA7-C7BB52369222}"/>
-                </a:ext>
-              </a:extLst>
-            </p:cNvPr>
-            <p:cNvSpPr/>
-            <p:nvPr/>
-          </p:nvSpPr>
-          <p:spPr>
-            <a:xfrm>
-              <a:off x="7200899" y="7812912"/>
-              <a:ext cx="3175" cy="3175"/>
-            </a:xfrm>
-            <a:custGeom>
-              <a:avLst/>
-              <a:gdLst/>
-              <a:ahLst/>
-              <a:cxnLst/>
-              <a:rect l="l" t="t" r="r" b="b"/>
-              <a:pathLst>
-                <a:path w="3175" h="3175">
-                  <a:moveTo>
-                    <a:pt x="3047" y="0"/>
-                  </a:moveTo>
-                  <a:lnTo>
-                    <a:pt x="0" y="0"/>
-                  </a:lnTo>
-                  <a:lnTo>
-                    <a:pt x="0" y="3047"/>
-                  </a:lnTo>
-                  <a:lnTo>
-                    <a:pt x="3047" y="3047"/>
-                  </a:lnTo>
-                  <a:lnTo>
-                    <a:pt x="3047" y="0"/>
-                  </a:lnTo>
-                  <a:close/>
-                </a:path>
-              </a:pathLst>
-            </a:custGeom>
-            <a:solidFill>
-              <a:srgbClr val="E2E2E2"/>
-            </a:solidFill>
-          </p:spPr>
-          <p:txBody>
-            <a:bodyPr wrap="square" lIns="0" tIns="0" rIns="0" bIns="0" rtlCol="0"/>
-            <a:lstStyle/>
-            <a:p>
-              <a:endParaRPr/>
-            </a:p>
-          </p:txBody>
-        </p:sp>
-        <p:sp>
-          <p:nvSpPr>
-            <p:cNvPr id="40" name="object 40">
-              <a:extLst>
-                <a:ext uri="{FF2B5EF4-FFF2-40B4-BE49-F238E27FC236}">
-                  <a16:creationId xmlns:a16="http://schemas.microsoft.com/office/drawing/2014/main" id="{87BDBD3E-C8C7-D992-85CD-1D77F69529EA}"/>
-                </a:ext>
-              </a:extLst>
-            </p:cNvPr>
-            <p:cNvSpPr/>
-            <p:nvPr/>
-          </p:nvSpPr>
-          <p:spPr>
-            <a:xfrm>
-              <a:off x="801928" y="7812925"/>
-              <a:ext cx="6402070" cy="17145"/>
-            </a:xfrm>
-            <a:custGeom>
-              <a:avLst/>
-              <a:gdLst/>
-              <a:ahLst/>
-              <a:cxnLst/>
-              <a:rect l="l" t="t" r="r" b="b"/>
-              <a:pathLst>
-                <a:path w="6402070" h="17145">
-                  <a:moveTo>
-                    <a:pt x="3048" y="3035"/>
-                  </a:moveTo>
-                  <a:lnTo>
-                    <a:pt x="0" y="3035"/>
-                  </a:lnTo>
-                  <a:lnTo>
-                    <a:pt x="0" y="16751"/>
-                  </a:lnTo>
-                  <a:lnTo>
-                    <a:pt x="3048" y="16751"/>
-                  </a:lnTo>
-                  <a:lnTo>
-                    <a:pt x="3048" y="3035"/>
-                  </a:lnTo>
-                  <a:close/>
-                </a:path>
-                <a:path w="6402070" h="17145">
-                  <a:moveTo>
-                    <a:pt x="6402006" y="0"/>
-                  </a:moveTo>
-                  <a:lnTo>
-                    <a:pt x="6398971" y="0"/>
-                  </a:lnTo>
-                  <a:lnTo>
-                    <a:pt x="6398971" y="3035"/>
-                  </a:lnTo>
-                  <a:lnTo>
-                    <a:pt x="6402006" y="3035"/>
-                  </a:lnTo>
-                  <a:lnTo>
-                    <a:pt x="6402006" y="0"/>
-                  </a:lnTo>
-                  <a:close/>
-                </a:path>
-              </a:pathLst>
-            </a:custGeom>
-            <a:solidFill>
-              <a:srgbClr val="9F9F9F"/>
-            </a:solidFill>
-          </p:spPr>
-          <p:txBody>
-            <a:bodyPr wrap="square" lIns="0" tIns="0" rIns="0" bIns="0" rtlCol="0"/>
-            <a:lstStyle/>
-            <a:p>
-              <a:endParaRPr/>
-            </a:p>
-          </p:txBody>
-        </p:sp>
-        <p:sp>
-          <p:nvSpPr>
-            <p:cNvPr id="41" name="object 41">
-              <a:extLst>
-                <a:ext uri="{FF2B5EF4-FFF2-40B4-BE49-F238E27FC236}">
-                  <a16:creationId xmlns:a16="http://schemas.microsoft.com/office/drawing/2014/main" id="{1CB04381-D201-EF29-AD41-3AFB9B108ABB}"/>
-                </a:ext>
-              </a:extLst>
-            </p:cNvPr>
-            <p:cNvSpPr/>
-            <p:nvPr/>
-          </p:nvSpPr>
-          <p:spPr>
-            <a:xfrm>
-              <a:off x="7200899" y="7815960"/>
-              <a:ext cx="3175" cy="13970"/>
-            </a:xfrm>
-            <a:custGeom>
-              <a:avLst/>
-              <a:gdLst/>
-              <a:ahLst/>
-              <a:cxnLst/>
-              <a:rect l="l" t="t" r="r" b="b"/>
-              <a:pathLst>
-                <a:path w="3175" h="13970">
-                  <a:moveTo>
-                    <a:pt x="3047" y="0"/>
-                  </a:moveTo>
-                  <a:lnTo>
-                    <a:pt x="0" y="0"/>
-                  </a:lnTo>
-                  <a:lnTo>
-                    <a:pt x="0" y="13716"/>
-                  </a:lnTo>
-                  <a:lnTo>
-                    <a:pt x="3047" y="13716"/>
-                  </a:lnTo>
-                  <a:lnTo>
-                    <a:pt x="3047" y="0"/>
-                  </a:lnTo>
-                  <a:close/>
-                </a:path>
-              </a:pathLst>
-            </a:custGeom>
-            <a:solidFill>
-              <a:srgbClr val="E2E2E2"/>
-            </a:solidFill>
-          </p:spPr>
-          <p:txBody>
-            <a:bodyPr wrap="square" lIns="0" tIns="0" rIns="0" bIns="0" rtlCol="0"/>
-            <a:lstStyle/>
-            <a:p>
-              <a:endParaRPr/>
-            </a:p>
-          </p:txBody>
-        </p:sp>
-        <p:sp>
-          <p:nvSpPr>
-            <p:cNvPr id="42" name="object 42">
-              <a:extLst>
-                <a:ext uri="{FF2B5EF4-FFF2-40B4-BE49-F238E27FC236}">
-                  <a16:creationId xmlns:a16="http://schemas.microsoft.com/office/drawing/2014/main" id="{211F987A-1E45-144C-781C-439392BB5503}"/>
-                </a:ext>
-              </a:extLst>
-            </p:cNvPr>
-            <p:cNvSpPr/>
-            <p:nvPr/>
-          </p:nvSpPr>
-          <p:spPr>
-            <a:xfrm>
-              <a:off x="801928" y="7829676"/>
-              <a:ext cx="3175" cy="3175"/>
-            </a:xfrm>
-            <a:custGeom>
-              <a:avLst/>
-              <a:gdLst/>
-              <a:ahLst/>
-              <a:cxnLst/>
-              <a:rect l="l" t="t" r="r" b="b"/>
-              <a:pathLst>
-                <a:path w="3175" h="3175">
-                  <a:moveTo>
-                    <a:pt x="3048" y="0"/>
-                  </a:moveTo>
-                  <a:lnTo>
-                    <a:pt x="0" y="0"/>
-                  </a:lnTo>
-                  <a:lnTo>
-                    <a:pt x="0" y="3047"/>
-                  </a:lnTo>
-                  <a:lnTo>
-                    <a:pt x="3048" y="3047"/>
-                  </a:lnTo>
-                  <a:lnTo>
-                    <a:pt x="3048" y="0"/>
-                  </a:lnTo>
-                  <a:close/>
-                </a:path>
-              </a:pathLst>
-            </a:custGeom>
-            <a:solidFill>
-              <a:srgbClr val="9F9F9F"/>
-            </a:solidFill>
-          </p:spPr>
-          <p:txBody>
-            <a:bodyPr wrap="square" lIns="0" tIns="0" rIns="0" bIns="0" rtlCol="0"/>
-            <a:lstStyle/>
-            <a:p>
-              <a:endParaRPr/>
-            </a:p>
-          </p:txBody>
-        </p:sp>
-        <p:sp>
-          <p:nvSpPr>
-            <p:cNvPr id="43" name="object 43">
-              <a:extLst>
-                <a:ext uri="{FF2B5EF4-FFF2-40B4-BE49-F238E27FC236}">
-                  <a16:creationId xmlns:a16="http://schemas.microsoft.com/office/drawing/2014/main" id="{36F1915D-3794-8E80-8F51-6CFCAAD8563D}"/>
-                </a:ext>
-              </a:extLst>
-            </p:cNvPr>
-            <p:cNvSpPr/>
-            <p:nvPr/>
-          </p:nvSpPr>
-          <p:spPr>
-            <a:xfrm>
-              <a:off x="801928" y="7829689"/>
-              <a:ext cx="6402070" cy="3175"/>
-            </a:xfrm>
-            <a:custGeom>
-              <a:avLst/>
-              <a:gdLst/>
-              <a:ahLst/>
-              <a:cxnLst/>
-              <a:rect l="l" t="t" r="r" b="b"/>
-              <a:pathLst>
-                <a:path w="6402070" h="3175">
-                  <a:moveTo>
-                    <a:pt x="6402006" y="0"/>
-                  </a:moveTo>
-                  <a:lnTo>
-                    <a:pt x="6399022" y="0"/>
-                  </a:lnTo>
-                  <a:lnTo>
-                    <a:pt x="3048" y="0"/>
-                  </a:lnTo>
-                  <a:lnTo>
-                    <a:pt x="0" y="0"/>
-                  </a:lnTo>
-                  <a:lnTo>
-                    <a:pt x="0" y="3035"/>
-                  </a:lnTo>
-                  <a:lnTo>
-                    <a:pt x="3048" y="3035"/>
-                  </a:lnTo>
-                  <a:lnTo>
-                    <a:pt x="6398971" y="3035"/>
-                  </a:lnTo>
-                  <a:lnTo>
-                    <a:pt x="6402006" y="3035"/>
-                  </a:lnTo>
-                  <a:lnTo>
-                    <a:pt x="6402006" y="0"/>
-                  </a:lnTo>
-                  <a:close/>
-                </a:path>
-              </a:pathLst>
-            </a:custGeom>
-            <a:solidFill>
-              <a:srgbClr val="E2E2E2"/>
-            </a:solidFill>
-          </p:spPr>
-          <p:txBody>
-            <a:bodyPr wrap="square" lIns="0" tIns="0" rIns="0" bIns="0" rtlCol="0"/>
-            <a:lstStyle/>
-            <a:p>
-              <a:endParaRPr/>
-            </a:p>
-          </p:txBody>
-        </p:sp>
-      </p:grpSp>
-      <p:sp>
-        <p:nvSpPr>
-          <p:cNvPr id="44" name="object 44">
-            <a:extLst>
-              <a:ext uri="{FF2B5EF4-FFF2-40B4-BE49-F238E27FC236}">
-                <a16:creationId xmlns:a16="http://schemas.microsoft.com/office/drawing/2014/main" id="{A8350C30-62E4-4069-0527-5B936BEB3002}"/>
-              </a:ext>
-            </a:extLst>
-          </p:cNvPr>
-          <p:cNvSpPr txBox="1"/>
-          <p:nvPr/>
-        </p:nvSpPr>
-        <p:spPr>
-          <a:xfrm>
-            <a:off x="734047" y="8921270"/>
-            <a:ext cx="6414135" cy="1100301"/>
-          </a:xfrm>
-          <a:prstGeom prst="rect">
-            <a:avLst/>
-          </a:prstGeom>
-        </p:spPr>
-        <p:txBody>
-          <a:bodyPr vert="horz" wrap="square" lIns="0" tIns="12700" rIns="0" bIns="0" rtlCol="0">
-            <a:spAutoFit/>
-          </a:bodyPr>
-          <a:lstStyle/>
-          <a:p>
-            <a:pPr marL="12700">
-              <a:lnSpc>
-                <a:spcPct val="100000"/>
-              </a:lnSpc>
-              <a:spcBef>
-                <a:spcPts val="100"/>
-              </a:spcBef>
-            </a:pPr>
-            <a:r>
-              <a:rPr sz="1400" b="1" dirty="0">
-                <a:solidFill>
-                  <a:srgbClr val="3B78D7"/>
-                </a:solidFill>
-                <a:latin typeface="Times New Roman"/>
-                <a:cs typeface="Times New Roman"/>
-              </a:rPr>
-              <a:t>8.</a:t>
-            </a:r>
-            <a:r>
-              <a:rPr sz="1400" b="1" spc="-5" dirty="0">
-                <a:solidFill>
-                  <a:srgbClr val="3B78D7"/>
-                </a:solidFill>
-                <a:latin typeface="Times New Roman"/>
-                <a:cs typeface="Times New Roman"/>
-              </a:rPr>
-              <a:t> </a:t>
-            </a:r>
-            <a:r>
-              <a:rPr sz="1400" b="1" spc="-10" dirty="0">
-                <a:solidFill>
-                  <a:srgbClr val="3B78D7"/>
-                </a:solidFill>
-                <a:latin typeface="Times New Roman"/>
-                <a:cs typeface="Times New Roman"/>
-              </a:rPr>
-              <a:t>Conclusion:</a:t>
-            </a:r>
-            <a:endParaRPr sz="1400" dirty="0">
-              <a:latin typeface="Times New Roman"/>
-              <a:cs typeface="Times New Roman"/>
-            </a:endParaRPr>
-          </a:p>
-          <a:p>
-            <a:pPr marL="106680" marR="5080">
-              <a:lnSpc>
-                <a:spcPts val="1380"/>
-              </a:lnSpc>
-              <a:spcBef>
-                <a:spcPts val="1235"/>
-              </a:spcBef>
-            </a:pPr>
-            <a:r>
-              <a:rPr lang="en-US" sz="1300" dirty="0">
-                <a:latin typeface="Times New Roman"/>
-                <a:cs typeface="Times New Roman"/>
-              </a:rPr>
-              <a:t>The project successfully integrates HTML, CSS, and JavaScript to form a complete registration system. The validation logic ensures data quality, while the dynamic table update provides immediate satisfaction to the user, proving that client-side scripting is essential for a modern web experience.</a:t>
-            </a:r>
-            <a:endParaRPr sz="1300" dirty="0">
-              <a:latin typeface="Times New Roman"/>
-              <a:cs typeface="Times New Roman"/>
-            </a:endParaRPr>
-          </a:p>
-        </p:txBody>
-      </p:sp>
       <p:pic>
         <p:nvPicPr>
           <p:cNvPr id="45" name="object 45">
@@ -9827,10 +8813,1317 @@
       </p:pic>
       <p:pic>
         <p:nvPicPr>
+          <p:cNvPr id="6" name="Picture 5">
+            <a:extLst>
+              <a:ext uri="{FF2B5EF4-FFF2-40B4-BE49-F238E27FC236}">
+                <a16:creationId xmlns:a16="http://schemas.microsoft.com/office/drawing/2014/main" id="{B94C2DBF-2BFB-010F-2AAE-AA7E07D426D1}"/>
+              </a:ext>
+            </a:extLst>
+          </p:cNvPr>
+          <p:cNvPicPr>
+            <a:picLocks noChangeAspect="1"/>
+          </p:cNvPicPr>
+          <p:nvPr/>
+        </p:nvPicPr>
+        <p:blipFill>
+          <a:blip r:embed="rId6">
+            <a:extLst>
+              <a:ext uri="{28A0092B-C50C-407E-A947-70E740481C1C}">
+                <a14:useLocalDpi xmlns:a14="http://schemas.microsoft.com/office/drawing/2010/main" val="0"/>
+              </a:ext>
+            </a:extLst>
+          </a:blip>
+          <a:stretch>
+            <a:fillRect/>
+          </a:stretch>
+        </p:blipFill>
+        <p:spPr>
+          <a:xfrm>
+            <a:off x="0" y="1539875"/>
+            <a:ext cx="3474720" cy="2779776"/>
+          </a:xfrm>
+          <a:prstGeom prst="rect">
+            <a:avLst/>
+          </a:prstGeom>
+        </p:spPr>
+      </p:pic>
+      <p:pic>
+        <p:nvPicPr>
+          <p:cNvPr id="11" name="Picture 10">
+            <a:extLst>
+              <a:ext uri="{FF2B5EF4-FFF2-40B4-BE49-F238E27FC236}">
+                <a16:creationId xmlns:a16="http://schemas.microsoft.com/office/drawing/2014/main" id="{0A481255-9E89-2C84-57F1-2E3F5997ACB0}"/>
+              </a:ext>
+            </a:extLst>
+          </p:cNvPr>
+          <p:cNvPicPr>
+            <a:picLocks noChangeAspect="1"/>
+          </p:cNvPicPr>
+          <p:nvPr/>
+        </p:nvPicPr>
+        <p:blipFill>
+          <a:blip r:embed="rId7">
+            <a:extLst>
+              <a:ext uri="{28A0092B-C50C-407E-A947-70E740481C1C}">
+                <a14:useLocalDpi xmlns:a14="http://schemas.microsoft.com/office/drawing/2010/main" val="0"/>
+              </a:ext>
+            </a:extLst>
+          </a:blip>
+          <a:stretch>
+            <a:fillRect/>
+          </a:stretch>
+        </p:blipFill>
+        <p:spPr>
+          <a:xfrm>
+            <a:off x="3784600" y="1539875"/>
+            <a:ext cx="3474720" cy="3078988"/>
+          </a:xfrm>
+          <a:prstGeom prst="rect">
+            <a:avLst/>
+          </a:prstGeom>
+        </p:spPr>
+      </p:pic>
+      <p:pic>
+        <p:nvPicPr>
+          <p:cNvPr id="13" name="Picture 12">
+            <a:extLst>
+              <a:ext uri="{FF2B5EF4-FFF2-40B4-BE49-F238E27FC236}">
+                <a16:creationId xmlns:a16="http://schemas.microsoft.com/office/drawing/2014/main" id="{E050F338-1DD4-571E-A549-16A88B044F6F}"/>
+              </a:ext>
+            </a:extLst>
+          </p:cNvPr>
+          <p:cNvPicPr>
+            <a:picLocks noChangeAspect="1"/>
+          </p:cNvPicPr>
+          <p:nvPr/>
+        </p:nvPicPr>
+        <p:blipFill>
+          <a:blip r:embed="rId8">
+            <a:extLst>
+              <a:ext uri="{28A0092B-C50C-407E-A947-70E740481C1C}">
+                <a14:useLocalDpi xmlns:a14="http://schemas.microsoft.com/office/drawing/2010/main" val="0"/>
+              </a:ext>
+            </a:extLst>
+          </a:blip>
+          <a:stretch>
+            <a:fillRect/>
+          </a:stretch>
+        </p:blipFill>
+        <p:spPr>
+          <a:xfrm>
+            <a:off x="279628" y="5572705"/>
+            <a:ext cx="3474720" cy="3587170"/>
+          </a:xfrm>
+          <a:prstGeom prst="rect">
+            <a:avLst/>
+          </a:prstGeom>
+        </p:spPr>
+      </p:pic>
+      <p:pic>
+        <p:nvPicPr>
+          <p:cNvPr id="15" name="Picture 14">
+            <a:extLst>
+              <a:ext uri="{FF2B5EF4-FFF2-40B4-BE49-F238E27FC236}">
+                <a16:creationId xmlns:a16="http://schemas.microsoft.com/office/drawing/2014/main" id="{3C547904-FA0C-6F4D-CA41-5D20AD545790}"/>
+              </a:ext>
+            </a:extLst>
+          </p:cNvPr>
+          <p:cNvPicPr>
+            <a:picLocks noChangeAspect="1"/>
+          </p:cNvPicPr>
+          <p:nvPr/>
+        </p:nvPicPr>
+        <p:blipFill>
+          <a:blip r:embed="rId9">
+            <a:extLst>
+              <a:ext uri="{28A0092B-C50C-407E-A947-70E740481C1C}">
+                <a14:useLocalDpi xmlns:a14="http://schemas.microsoft.com/office/drawing/2010/main" val="0"/>
+              </a:ext>
+            </a:extLst>
+          </a:blip>
+          <a:stretch>
+            <a:fillRect/>
+          </a:stretch>
+        </p:blipFill>
+        <p:spPr>
+          <a:xfrm>
+            <a:off x="3958297" y="5555361"/>
+            <a:ext cx="3474720" cy="3621858"/>
+          </a:xfrm>
+          <a:prstGeom prst="rect">
+            <a:avLst/>
+          </a:prstGeom>
+        </p:spPr>
+      </p:pic>
+    </p:spTree>
+    <p:extLst>
+      <p:ext uri="{BB962C8B-B14F-4D97-AF65-F5344CB8AC3E}">
+        <p14:creationId xmlns:p14="http://schemas.microsoft.com/office/powerpoint/2010/main" val="2896398324"/>
+      </p:ext>
+    </p:extLst>
+  </p:cSld>
+  <p:clrMapOvr>
+    <a:masterClrMapping/>
+  </p:clrMapOvr>
+</p:sld>
+</file>
+
+<file path=ppt/slides/slide5.xml><?xml version="1.0" encoding="utf-8"?>
+<p:sld xmlns:a="http://schemas.openxmlformats.org/drawingml/2006/main" xmlns:r="http://schemas.openxmlformats.org/officeDocument/2006/relationships" xmlns:p="http://schemas.openxmlformats.org/presentationml/2006/main" showMasterSp="0">
+  <p:cSld>
+    <p:spTree>
+      <p:nvGrpSpPr>
+        <p:cNvPr id="1" name="">
+          <a:extLst>
+            <a:ext uri="{FF2B5EF4-FFF2-40B4-BE49-F238E27FC236}">
+              <a16:creationId xmlns:a16="http://schemas.microsoft.com/office/drawing/2014/main" id="{13918351-29E2-D76D-1FED-56D4707ACBED}"/>
+            </a:ext>
+          </a:extLst>
+        </p:cNvPr>
+        <p:cNvGrpSpPr/>
+        <p:nvPr/>
+      </p:nvGrpSpPr>
+      <p:grpSpPr>
+        <a:xfrm>
+          <a:off x="0" y="0"/>
+          <a:ext cx="0" cy="0"/>
+          <a:chOff x="0" y="0"/>
+          <a:chExt cx="0" cy="0"/>
+        </a:xfrm>
+      </p:grpSpPr>
+      <p:pic>
+        <p:nvPicPr>
+          <p:cNvPr id="2" name="object 2">
+            <a:extLst>
+              <a:ext uri="{FF2B5EF4-FFF2-40B4-BE49-F238E27FC236}">
+                <a16:creationId xmlns:a16="http://schemas.microsoft.com/office/drawing/2014/main" id="{C7395E98-6A20-E1EC-48B1-B8F87B928EE8}"/>
+              </a:ext>
+            </a:extLst>
+          </p:cNvPr>
+          <p:cNvPicPr/>
+          <p:nvPr/>
+        </p:nvPicPr>
+        <p:blipFill>
+          <a:blip r:embed="rId2" cstate="print"/>
+          <a:stretch>
+            <a:fillRect/>
+          </a:stretch>
+        </p:blipFill>
+        <p:spPr>
+          <a:xfrm>
+            <a:off x="4416425" y="644562"/>
+            <a:ext cx="996314" cy="434174"/>
+          </a:xfrm>
+          <a:prstGeom prst="rect">
+            <a:avLst/>
+          </a:prstGeom>
+        </p:spPr>
+      </p:pic>
+      <p:pic>
+        <p:nvPicPr>
+          <p:cNvPr id="3" name="object 3">
+            <a:extLst>
+              <a:ext uri="{FF2B5EF4-FFF2-40B4-BE49-F238E27FC236}">
+                <a16:creationId xmlns:a16="http://schemas.microsoft.com/office/drawing/2014/main" id="{76D0AAEE-AA8A-E512-BCE0-101AF2B8DA0B}"/>
+              </a:ext>
+            </a:extLst>
+          </p:cNvPr>
+          <p:cNvPicPr/>
+          <p:nvPr/>
+        </p:nvPicPr>
+        <p:blipFill>
+          <a:blip r:embed="rId3" cstate="print"/>
+          <a:stretch>
+            <a:fillRect/>
+          </a:stretch>
+        </p:blipFill>
+        <p:spPr>
+          <a:xfrm>
+            <a:off x="6073775" y="665479"/>
+            <a:ext cx="1074407" cy="401954"/>
+          </a:xfrm>
+          <a:prstGeom prst="rect">
+            <a:avLst/>
+          </a:prstGeom>
+        </p:spPr>
+      </p:pic>
+      <p:grpSp>
+        <p:nvGrpSpPr>
+          <p:cNvPr id="29" name="object 29">
+            <a:extLst>
+              <a:ext uri="{FF2B5EF4-FFF2-40B4-BE49-F238E27FC236}">
+                <a16:creationId xmlns:a16="http://schemas.microsoft.com/office/drawing/2014/main" id="{ACC51D0F-2CB6-7556-DC09-C43C2212855B}"/>
+              </a:ext>
+            </a:extLst>
+          </p:cNvPr>
+          <p:cNvGrpSpPr/>
+          <p:nvPr/>
+        </p:nvGrpSpPr>
+        <p:grpSpPr>
+          <a:xfrm>
+            <a:off x="801369" y="6473824"/>
+            <a:ext cx="6402705" cy="20955"/>
+            <a:chOff x="801369" y="6473824"/>
+            <a:chExt cx="6402705" cy="20955"/>
+          </a:xfrm>
+        </p:grpSpPr>
+        <p:sp>
+          <p:nvSpPr>
+            <p:cNvPr id="30" name="object 30">
+              <a:extLst>
+                <a:ext uri="{FF2B5EF4-FFF2-40B4-BE49-F238E27FC236}">
+                  <a16:creationId xmlns:a16="http://schemas.microsoft.com/office/drawing/2014/main" id="{4E5F7915-0FFA-D369-E35C-6182C31623B5}"/>
+                </a:ext>
+              </a:extLst>
+            </p:cNvPr>
+            <p:cNvSpPr/>
+            <p:nvPr/>
+          </p:nvSpPr>
+          <p:spPr>
+            <a:xfrm>
+              <a:off x="801370" y="6473824"/>
+              <a:ext cx="6400800" cy="19685"/>
+            </a:xfrm>
+            <a:custGeom>
+              <a:avLst/>
+              <a:gdLst/>
+              <a:ahLst/>
+              <a:cxnLst/>
+              <a:rect l="l" t="t" r="r" b="b"/>
+              <a:pathLst>
+                <a:path w="6400800" h="19685">
+                  <a:moveTo>
+                    <a:pt x="6400800" y="0"/>
+                  </a:moveTo>
+                  <a:lnTo>
+                    <a:pt x="0" y="0"/>
+                  </a:lnTo>
+                  <a:lnTo>
+                    <a:pt x="0" y="19685"/>
+                  </a:lnTo>
+                  <a:lnTo>
+                    <a:pt x="6400800" y="19685"/>
+                  </a:lnTo>
+                  <a:lnTo>
+                    <a:pt x="6400800" y="0"/>
+                  </a:lnTo>
+                  <a:close/>
+                </a:path>
+              </a:pathLst>
+            </a:custGeom>
+            <a:solidFill>
+              <a:srgbClr val="9F9F9F"/>
+            </a:solidFill>
+          </p:spPr>
+          <p:txBody>
+            <a:bodyPr wrap="square" lIns="0" tIns="0" rIns="0" bIns="0" rtlCol="0"/>
+            <a:lstStyle/>
+            <a:p>
+              <a:endParaRPr/>
+            </a:p>
+          </p:txBody>
+        </p:sp>
+        <p:sp>
+          <p:nvSpPr>
+            <p:cNvPr id="31" name="object 31">
+              <a:extLst>
+                <a:ext uri="{FF2B5EF4-FFF2-40B4-BE49-F238E27FC236}">
+                  <a16:creationId xmlns:a16="http://schemas.microsoft.com/office/drawing/2014/main" id="{2DB2C99D-CA2E-894B-00DE-91A8C61FC2EC}"/>
+                </a:ext>
+              </a:extLst>
+            </p:cNvPr>
+            <p:cNvSpPr/>
+            <p:nvPr/>
+          </p:nvSpPr>
+          <p:spPr>
+            <a:xfrm>
+              <a:off x="7200899" y="6474840"/>
+              <a:ext cx="3175" cy="3175"/>
+            </a:xfrm>
+            <a:custGeom>
+              <a:avLst/>
+              <a:gdLst/>
+              <a:ahLst/>
+              <a:cxnLst/>
+              <a:rect l="l" t="t" r="r" b="b"/>
+              <a:pathLst>
+                <a:path w="3175" h="3175">
+                  <a:moveTo>
+                    <a:pt x="3047" y="0"/>
+                  </a:moveTo>
+                  <a:lnTo>
+                    <a:pt x="0" y="0"/>
+                  </a:lnTo>
+                  <a:lnTo>
+                    <a:pt x="0" y="3047"/>
+                  </a:lnTo>
+                  <a:lnTo>
+                    <a:pt x="3047" y="3047"/>
+                  </a:lnTo>
+                  <a:lnTo>
+                    <a:pt x="3047" y="0"/>
+                  </a:lnTo>
+                  <a:close/>
+                </a:path>
+              </a:pathLst>
+            </a:custGeom>
+            <a:solidFill>
+              <a:srgbClr val="E2E2E2"/>
+            </a:solidFill>
+          </p:spPr>
+          <p:txBody>
+            <a:bodyPr wrap="square" lIns="0" tIns="0" rIns="0" bIns="0" rtlCol="0"/>
+            <a:lstStyle/>
+            <a:p>
+              <a:endParaRPr/>
+            </a:p>
+          </p:txBody>
+        </p:sp>
+        <p:sp>
+          <p:nvSpPr>
+            <p:cNvPr id="32" name="object 32">
+              <a:extLst>
+                <a:ext uri="{FF2B5EF4-FFF2-40B4-BE49-F238E27FC236}">
+                  <a16:creationId xmlns:a16="http://schemas.microsoft.com/office/drawing/2014/main" id="{F82D9680-D36E-DCEB-CAEF-CBB0F1BCE207}"/>
+                </a:ext>
+              </a:extLst>
+            </p:cNvPr>
+            <p:cNvSpPr/>
+            <p:nvPr/>
+          </p:nvSpPr>
+          <p:spPr>
+            <a:xfrm>
+              <a:off x="801928" y="6474853"/>
+              <a:ext cx="6402070" cy="17145"/>
+            </a:xfrm>
+            <a:custGeom>
+              <a:avLst/>
+              <a:gdLst/>
+              <a:ahLst/>
+              <a:cxnLst/>
+              <a:rect l="l" t="t" r="r" b="b"/>
+              <a:pathLst>
+                <a:path w="6402070" h="17145">
+                  <a:moveTo>
+                    <a:pt x="3048" y="3048"/>
+                  </a:moveTo>
+                  <a:lnTo>
+                    <a:pt x="0" y="3048"/>
+                  </a:lnTo>
+                  <a:lnTo>
+                    <a:pt x="0" y="16751"/>
+                  </a:lnTo>
+                  <a:lnTo>
+                    <a:pt x="3048" y="16751"/>
+                  </a:lnTo>
+                  <a:lnTo>
+                    <a:pt x="3048" y="3048"/>
+                  </a:lnTo>
+                  <a:close/>
+                </a:path>
+                <a:path w="6402070" h="17145">
+                  <a:moveTo>
+                    <a:pt x="6402006" y="0"/>
+                  </a:moveTo>
+                  <a:lnTo>
+                    <a:pt x="6398971" y="0"/>
+                  </a:lnTo>
+                  <a:lnTo>
+                    <a:pt x="6398971" y="3035"/>
+                  </a:lnTo>
+                  <a:lnTo>
+                    <a:pt x="6402006" y="3035"/>
+                  </a:lnTo>
+                  <a:lnTo>
+                    <a:pt x="6402006" y="0"/>
+                  </a:lnTo>
+                  <a:close/>
+                </a:path>
+              </a:pathLst>
+            </a:custGeom>
+            <a:solidFill>
+              <a:srgbClr val="9F9F9F"/>
+            </a:solidFill>
+          </p:spPr>
+          <p:txBody>
+            <a:bodyPr wrap="square" lIns="0" tIns="0" rIns="0" bIns="0" rtlCol="0"/>
+            <a:lstStyle/>
+            <a:p>
+              <a:endParaRPr/>
+            </a:p>
+          </p:txBody>
+        </p:sp>
+        <p:sp>
+          <p:nvSpPr>
+            <p:cNvPr id="33" name="object 33">
+              <a:extLst>
+                <a:ext uri="{FF2B5EF4-FFF2-40B4-BE49-F238E27FC236}">
+                  <a16:creationId xmlns:a16="http://schemas.microsoft.com/office/drawing/2014/main" id="{6E45B4E0-B0E0-64BF-4848-34588FEE044E}"/>
+                </a:ext>
+              </a:extLst>
+            </p:cNvPr>
+            <p:cNvSpPr/>
+            <p:nvPr/>
+          </p:nvSpPr>
+          <p:spPr>
+            <a:xfrm>
+              <a:off x="7200899" y="6477888"/>
+              <a:ext cx="3175" cy="13970"/>
+            </a:xfrm>
+            <a:custGeom>
+              <a:avLst/>
+              <a:gdLst/>
+              <a:ahLst/>
+              <a:cxnLst/>
+              <a:rect l="l" t="t" r="r" b="b"/>
+              <a:pathLst>
+                <a:path w="3175" h="13970">
+                  <a:moveTo>
+                    <a:pt x="3047" y="0"/>
+                  </a:moveTo>
+                  <a:lnTo>
+                    <a:pt x="0" y="0"/>
+                  </a:lnTo>
+                  <a:lnTo>
+                    <a:pt x="0" y="13715"/>
+                  </a:lnTo>
+                  <a:lnTo>
+                    <a:pt x="3047" y="13715"/>
+                  </a:lnTo>
+                  <a:lnTo>
+                    <a:pt x="3047" y="0"/>
+                  </a:lnTo>
+                  <a:close/>
+                </a:path>
+              </a:pathLst>
+            </a:custGeom>
+            <a:solidFill>
+              <a:srgbClr val="E2E2E2"/>
+            </a:solidFill>
+          </p:spPr>
+          <p:txBody>
+            <a:bodyPr wrap="square" lIns="0" tIns="0" rIns="0" bIns="0" rtlCol="0"/>
+            <a:lstStyle/>
+            <a:p>
+              <a:endParaRPr/>
+            </a:p>
+          </p:txBody>
+        </p:sp>
+        <p:sp>
+          <p:nvSpPr>
+            <p:cNvPr id="34" name="object 34">
+              <a:extLst>
+                <a:ext uri="{FF2B5EF4-FFF2-40B4-BE49-F238E27FC236}">
+                  <a16:creationId xmlns:a16="http://schemas.microsoft.com/office/drawing/2014/main" id="{268B20D4-F3A1-2038-25EB-1C2DF0AE6B34}"/>
+                </a:ext>
+              </a:extLst>
+            </p:cNvPr>
+            <p:cNvSpPr/>
+            <p:nvPr/>
+          </p:nvSpPr>
+          <p:spPr>
+            <a:xfrm>
+              <a:off x="801928" y="6491604"/>
+              <a:ext cx="3175" cy="3175"/>
+            </a:xfrm>
+            <a:custGeom>
+              <a:avLst/>
+              <a:gdLst/>
+              <a:ahLst/>
+              <a:cxnLst/>
+              <a:rect l="l" t="t" r="r" b="b"/>
+              <a:pathLst>
+                <a:path w="3175" h="3175">
+                  <a:moveTo>
+                    <a:pt x="3048" y="0"/>
+                  </a:moveTo>
+                  <a:lnTo>
+                    <a:pt x="0" y="0"/>
+                  </a:lnTo>
+                  <a:lnTo>
+                    <a:pt x="0" y="3047"/>
+                  </a:lnTo>
+                  <a:lnTo>
+                    <a:pt x="3048" y="3047"/>
+                  </a:lnTo>
+                  <a:lnTo>
+                    <a:pt x="3048" y="0"/>
+                  </a:lnTo>
+                  <a:close/>
+                </a:path>
+              </a:pathLst>
+            </a:custGeom>
+            <a:solidFill>
+              <a:srgbClr val="9F9F9F"/>
+            </a:solidFill>
+          </p:spPr>
+          <p:txBody>
+            <a:bodyPr wrap="square" lIns="0" tIns="0" rIns="0" bIns="0" rtlCol="0"/>
+            <a:lstStyle/>
+            <a:p>
+              <a:endParaRPr/>
+            </a:p>
+          </p:txBody>
+        </p:sp>
+        <p:sp>
+          <p:nvSpPr>
+            <p:cNvPr id="35" name="object 35">
+              <a:extLst>
+                <a:ext uri="{FF2B5EF4-FFF2-40B4-BE49-F238E27FC236}">
+                  <a16:creationId xmlns:a16="http://schemas.microsoft.com/office/drawing/2014/main" id="{40F6CB7C-61BE-2CD2-FCB1-51FF2F50E1EC}"/>
+                </a:ext>
+              </a:extLst>
+            </p:cNvPr>
+            <p:cNvSpPr/>
+            <p:nvPr/>
+          </p:nvSpPr>
+          <p:spPr>
+            <a:xfrm>
+              <a:off x="801928" y="6491617"/>
+              <a:ext cx="6402070" cy="3175"/>
+            </a:xfrm>
+            <a:custGeom>
+              <a:avLst/>
+              <a:gdLst/>
+              <a:ahLst/>
+              <a:cxnLst/>
+              <a:rect l="l" t="t" r="r" b="b"/>
+              <a:pathLst>
+                <a:path w="6402070" h="3175">
+                  <a:moveTo>
+                    <a:pt x="6402006" y="0"/>
+                  </a:moveTo>
+                  <a:lnTo>
+                    <a:pt x="6399022" y="0"/>
+                  </a:lnTo>
+                  <a:lnTo>
+                    <a:pt x="3048" y="0"/>
+                  </a:lnTo>
+                  <a:lnTo>
+                    <a:pt x="0" y="0"/>
+                  </a:lnTo>
+                  <a:lnTo>
+                    <a:pt x="0" y="3035"/>
+                  </a:lnTo>
+                  <a:lnTo>
+                    <a:pt x="3048" y="3035"/>
+                  </a:lnTo>
+                  <a:lnTo>
+                    <a:pt x="6398971" y="3035"/>
+                  </a:lnTo>
+                  <a:lnTo>
+                    <a:pt x="6402006" y="3035"/>
+                  </a:lnTo>
+                  <a:lnTo>
+                    <a:pt x="6402006" y="0"/>
+                  </a:lnTo>
+                  <a:close/>
+                </a:path>
+              </a:pathLst>
+            </a:custGeom>
+            <a:solidFill>
+              <a:srgbClr val="E2E2E2"/>
+            </a:solidFill>
+          </p:spPr>
+          <p:txBody>
+            <a:bodyPr wrap="square" lIns="0" tIns="0" rIns="0" bIns="0" rtlCol="0"/>
+            <a:lstStyle/>
+            <a:p>
+              <a:endParaRPr/>
+            </a:p>
+          </p:txBody>
+        </p:sp>
+      </p:grpSp>
+      <p:sp>
+        <p:nvSpPr>
+          <p:cNvPr id="36" name="object 36">
+            <a:extLst>
+              <a:ext uri="{FF2B5EF4-FFF2-40B4-BE49-F238E27FC236}">
+                <a16:creationId xmlns:a16="http://schemas.microsoft.com/office/drawing/2014/main" id="{FEE54F4A-8D18-B4C2-3886-833F88B9C603}"/>
+              </a:ext>
+            </a:extLst>
+          </p:cNvPr>
+          <p:cNvSpPr txBox="1"/>
+          <p:nvPr/>
+        </p:nvSpPr>
+        <p:spPr>
+          <a:xfrm>
+            <a:off x="789228" y="6661784"/>
+            <a:ext cx="5911850" cy="1690847"/>
+          </a:xfrm>
+          <a:prstGeom prst="rect">
+            <a:avLst/>
+          </a:prstGeom>
+        </p:spPr>
+        <p:txBody>
+          <a:bodyPr vert="horz" wrap="square" lIns="0" tIns="13335" rIns="0" bIns="0" rtlCol="0">
+            <a:spAutoFit/>
+          </a:bodyPr>
+          <a:lstStyle/>
+          <a:p>
+            <a:pPr marL="12700">
+              <a:lnSpc>
+                <a:spcPct val="100000"/>
+              </a:lnSpc>
+              <a:spcBef>
+                <a:spcPts val="105"/>
+              </a:spcBef>
+            </a:pPr>
+            <a:r>
+              <a:rPr sz="1400" b="1" dirty="0">
+                <a:solidFill>
+                  <a:srgbClr val="3B78D7"/>
+                </a:solidFill>
+                <a:latin typeface="Times New Roman"/>
+                <a:cs typeface="Times New Roman"/>
+              </a:rPr>
+              <a:t>7.Learning</a:t>
+            </a:r>
+            <a:r>
+              <a:rPr sz="1400" b="1" spc="-45" dirty="0">
+                <a:solidFill>
+                  <a:srgbClr val="3B78D7"/>
+                </a:solidFill>
+                <a:latin typeface="Times New Roman"/>
+                <a:cs typeface="Times New Roman"/>
+              </a:rPr>
+              <a:t> </a:t>
+            </a:r>
+            <a:r>
+              <a:rPr sz="1400" b="1" spc="-10" dirty="0">
+                <a:solidFill>
+                  <a:srgbClr val="3B78D7"/>
+                </a:solidFill>
+                <a:latin typeface="Times New Roman"/>
+                <a:cs typeface="Times New Roman"/>
+              </a:rPr>
+              <a:t>Outcome:</a:t>
+            </a:r>
+            <a:endParaRPr sz="1400" dirty="0">
+              <a:latin typeface="Times New Roman"/>
+              <a:cs typeface="Times New Roman"/>
+            </a:endParaRPr>
+          </a:p>
+          <a:p>
+            <a:pPr marL="109855" marR="5080">
+              <a:lnSpc>
+                <a:spcPts val="1380"/>
+              </a:lnSpc>
+              <a:spcBef>
+                <a:spcPts val="1025"/>
+              </a:spcBef>
+            </a:pPr>
+            <a:r>
+              <a:rPr lang="en-US" sz="1300" b="1" dirty="0">
+                <a:latin typeface="Times New Roman"/>
+                <a:cs typeface="Times New Roman"/>
+              </a:rPr>
+              <a:t>Interactivity</a:t>
+            </a:r>
+            <a:r>
+              <a:rPr lang="en-US" sz="1300" dirty="0">
+                <a:latin typeface="Times New Roman"/>
+                <a:cs typeface="Times New Roman"/>
+              </a:rPr>
+              <a:t>: I learned how to move beyond static styling and create a functional web application using JavaScript.</a:t>
+            </a:r>
+          </a:p>
+          <a:p>
+            <a:pPr marL="109855" marR="5080">
+              <a:lnSpc>
+                <a:spcPts val="1380"/>
+              </a:lnSpc>
+              <a:spcBef>
+                <a:spcPts val="1025"/>
+              </a:spcBef>
+            </a:pPr>
+            <a:r>
+              <a:rPr lang="en-US" sz="1300" b="1" dirty="0">
+                <a:latin typeface="Times New Roman"/>
+                <a:cs typeface="Times New Roman"/>
+              </a:rPr>
+              <a:t>Data Integrity</a:t>
+            </a:r>
+            <a:r>
+              <a:rPr lang="en-US" sz="1300" dirty="0">
+                <a:latin typeface="Times New Roman"/>
+                <a:cs typeface="Times New Roman"/>
+              </a:rPr>
+              <a:t>: I understood how to enforce rules on user input to ensure the database (or table) only receives correctly formatted information.</a:t>
+            </a:r>
+          </a:p>
+          <a:p>
+            <a:pPr marL="109855" marR="5080">
+              <a:lnSpc>
+                <a:spcPts val="1380"/>
+              </a:lnSpc>
+              <a:spcBef>
+                <a:spcPts val="1025"/>
+              </a:spcBef>
+            </a:pPr>
+            <a:r>
+              <a:rPr lang="en-US" sz="1300" b="1" dirty="0">
+                <a:latin typeface="Times New Roman"/>
+                <a:cs typeface="Times New Roman"/>
+              </a:rPr>
+              <a:t>DOM Skills</a:t>
+            </a:r>
+            <a:r>
+              <a:rPr lang="en-US" sz="1300" dirty="0">
+                <a:latin typeface="Times New Roman"/>
+                <a:cs typeface="Times New Roman"/>
+              </a:rPr>
+              <a:t>: I gained confidence in manipulating the Document Object Model to change page content dynamically without a server.</a:t>
+            </a:r>
+            <a:endParaRPr sz="1300" dirty="0">
+              <a:latin typeface="Times New Roman"/>
+              <a:cs typeface="Times New Roman"/>
+            </a:endParaRPr>
+          </a:p>
+        </p:txBody>
+      </p:sp>
+      <p:grpSp>
+        <p:nvGrpSpPr>
+          <p:cNvPr id="37" name="object 37">
+            <a:extLst>
+              <a:ext uri="{FF2B5EF4-FFF2-40B4-BE49-F238E27FC236}">
+                <a16:creationId xmlns:a16="http://schemas.microsoft.com/office/drawing/2014/main" id="{A73E787E-45C1-DD60-0357-45D77897E6F6}"/>
+              </a:ext>
+            </a:extLst>
+          </p:cNvPr>
+          <p:cNvGrpSpPr/>
+          <p:nvPr/>
+        </p:nvGrpSpPr>
+        <p:grpSpPr>
+          <a:xfrm>
+            <a:off x="789228" y="8778875"/>
+            <a:ext cx="6402705" cy="20955"/>
+            <a:chOff x="801369" y="7811769"/>
+            <a:chExt cx="6402705" cy="20955"/>
+          </a:xfrm>
+        </p:grpSpPr>
+        <p:sp>
+          <p:nvSpPr>
+            <p:cNvPr id="38" name="object 38">
+              <a:extLst>
+                <a:ext uri="{FF2B5EF4-FFF2-40B4-BE49-F238E27FC236}">
+                  <a16:creationId xmlns:a16="http://schemas.microsoft.com/office/drawing/2014/main" id="{5F42E02E-4019-95C7-99F8-3A3AFBEDA1A1}"/>
+                </a:ext>
+              </a:extLst>
+            </p:cNvPr>
+            <p:cNvSpPr/>
+            <p:nvPr/>
+          </p:nvSpPr>
+          <p:spPr>
+            <a:xfrm>
+              <a:off x="801370" y="7811769"/>
+              <a:ext cx="6400800" cy="20320"/>
+            </a:xfrm>
+            <a:custGeom>
+              <a:avLst/>
+              <a:gdLst/>
+              <a:ahLst/>
+              <a:cxnLst/>
+              <a:rect l="l" t="t" r="r" b="b"/>
+              <a:pathLst>
+                <a:path w="6400800" h="20320">
+                  <a:moveTo>
+                    <a:pt x="6400800" y="0"/>
+                  </a:moveTo>
+                  <a:lnTo>
+                    <a:pt x="0" y="0"/>
+                  </a:lnTo>
+                  <a:lnTo>
+                    <a:pt x="0" y="20320"/>
+                  </a:lnTo>
+                  <a:lnTo>
+                    <a:pt x="6400800" y="20320"/>
+                  </a:lnTo>
+                  <a:lnTo>
+                    <a:pt x="6400800" y="0"/>
+                  </a:lnTo>
+                  <a:close/>
+                </a:path>
+              </a:pathLst>
+            </a:custGeom>
+            <a:solidFill>
+              <a:srgbClr val="9F9F9F"/>
+            </a:solidFill>
+          </p:spPr>
+          <p:txBody>
+            <a:bodyPr wrap="square" lIns="0" tIns="0" rIns="0" bIns="0" rtlCol="0"/>
+            <a:lstStyle/>
+            <a:p>
+              <a:endParaRPr/>
+            </a:p>
+          </p:txBody>
+        </p:sp>
+        <p:sp>
+          <p:nvSpPr>
+            <p:cNvPr id="39" name="object 39">
+              <a:extLst>
+                <a:ext uri="{FF2B5EF4-FFF2-40B4-BE49-F238E27FC236}">
+                  <a16:creationId xmlns:a16="http://schemas.microsoft.com/office/drawing/2014/main" id="{298B2F9A-BCD7-FE6D-2DA0-3F914AF4A94F}"/>
+                </a:ext>
+              </a:extLst>
+            </p:cNvPr>
+            <p:cNvSpPr/>
+            <p:nvPr/>
+          </p:nvSpPr>
+          <p:spPr>
+            <a:xfrm>
+              <a:off x="7200899" y="7812912"/>
+              <a:ext cx="3175" cy="3175"/>
+            </a:xfrm>
+            <a:custGeom>
+              <a:avLst/>
+              <a:gdLst/>
+              <a:ahLst/>
+              <a:cxnLst/>
+              <a:rect l="l" t="t" r="r" b="b"/>
+              <a:pathLst>
+                <a:path w="3175" h="3175">
+                  <a:moveTo>
+                    <a:pt x="3047" y="0"/>
+                  </a:moveTo>
+                  <a:lnTo>
+                    <a:pt x="0" y="0"/>
+                  </a:lnTo>
+                  <a:lnTo>
+                    <a:pt x="0" y="3047"/>
+                  </a:lnTo>
+                  <a:lnTo>
+                    <a:pt x="3047" y="3047"/>
+                  </a:lnTo>
+                  <a:lnTo>
+                    <a:pt x="3047" y="0"/>
+                  </a:lnTo>
+                  <a:close/>
+                </a:path>
+              </a:pathLst>
+            </a:custGeom>
+            <a:solidFill>
+              <a:srgbClr val="E2E2E2"/>
+            </a:solidFill>
+          </p:spPr>
+          <p:txBody>
+            <a:bodyPr wrap="square" lIns="0" tIns="0" rIns="0" bIns="0" rtlCol="0"/>
+            <a:lstStyle/>
+            <a:p>
+              <a:endParaRPr/>
+            </a:p>
+          </p:txBody>
+        </p:sp>
+        <p:sp>
+          <p:nvSpPr>
+            <p:cNvPr id="40" name="object 40">
+              <a:extLst>
+                <a:ext uri="{FF2B5EF4-FFF2-40B4-BE49-F238E27FC236}">
+                  <a16:creationId xmlns:a16="http://schemas.microsoft.com/office/drawing/2014/main" id="{385EADFB-F88E-89BD-5A91-B4D4D1D069AE}"/>
+                </a:ext>
+              </a:extLst>
+            </p:cNvPr>
+            <p:cNvSpPr/>
+            <p:nvPr/>
+          </p:nvSpPr>
+          <p:spPr>
+            <a:xfrm>
+              <a:off x="801928" y="7812925"/>
+              <a:ext cx="6402070" cy="17145"/>
+            </a:xfrm>
+            <a:custGeom>
+              <a:avLst/>
+              <a:gdLst/>
+              <a:ahLst/>
+              <a:cxnLst/>
+              <a:rect l="l" t="t" r="r" b="b"/>
+              <a:pathLst>
+                <a:path w="6402070" h="17145">
+                  <a:moveTo>
+                    <a:pt x="3048" y="3035"/>
+                  </a:moveTo>
+                  <a:lnTo>
+                    <a:pt x="0" y="3035"/>
+                  </a:lnTo>
+                  <a:lnTo>
+                    <a:pt x="0" y="16751"/>
+                  </a:lnTo>
+                  <a:lnTo>
+                    <a:pt x="3048" y="16751"/>
+                  </a:lnTo>
+                  <a:lnTo>
+                    <a:pt x="3048" y="3035"/>
+                  </a:lnTo>
+                  <a:close/>
+                </a:path>
+                <a:path w="6402070" h="17145">
+                  <a:moveTo>
+                    <a:pt x="6402006" y="0"/>
+                  </a:moveTo>
+                  <a:lnTo>
+                    <a:pt x="6398971" y="0"/>
+                  </a:lnTo>
+                  <a:lnTo>
+                    <a:pt x="6398971" y="3035"/>
+                  </a:lnTo>
+                  <a:lnTo>
+                    <a:pt x="6402006" y="3035"/>
+                  </a:lnTo>
+                  <a:lnTo>
+                    <a:pt x="6402006" y="0"/>
+                  </a:lnTo>
+                  <a:close/>
+                </a:path>
+              </a:pathLst>
+            </a:custGeom>
+            <a:solidFill>
+              <a:srgbClr val="9F9F9F"/>
+            </a:solidFill>
+          </p:spPr>
+          <p:txBody>
+            <a:bodyPr wrap="square" lIns="0" tIns="0" rIns="0" bIns="0" rtlCol="0"/>
+            <a:lstStyle/>
+            <a:p>
+              <a:endParaRPr/>
+            </a:p>
+          </p:txBody>
+        </p:sp>
+        <p:sp>
+          <p:nvSpPr>
+            <p:cNvPr id="41" name="object 41">
+              <a:extLst>
+                <a:ext uri="{FF2B5EF4-FFF2-40B4-BE49-F238E27FC236}">
+                  <a16:creationId xmlns:a16="http://schemas.microsoft.com/office/drawing/2014/main" id="{BE9BF930-354F-EA55-BEAA-58457AC12B10}"/>
+                </a:ext>
+              </a:extLst>
+            </p:cNvPr>
+            <p:cNvSpPr/>
+            <p:nvPr/>
+          </p:nvSpPr>
+          <p:spPr>
+            <a:xfrm>
+              <a:off x="7200899" y="7815960"/>
+              <a:ext cx="3175" cy="13970"/>
+            </a:xfrm>
+            <a:custGeom>
+              <a:avLst/>
+              <a:gdLst/>
+              <a:ahLst/>
+              <a:cxnLst/>
+              <a:rect l="l" t="t" r="r" b="b"/>
+              <a:pathLst>
+                <a:path w="3175" h="13970">
+                  <a:moveTo>
+                    <a:pt x="3047" y="0"/>
+                  </a:moveTo>
+                  <a:lnTo>
+                    <a:pt x="0" y="0"/>
+                  </a:lnTo>
+                  <a:lnTo>
+                    <a:pt x="0" y="13716"/>
+                  </a:lnTo>
+                  <a:lnTo>
+                    <a:pt x="3047" y="13716"/>
+                  </a:lnTo>
+                  <a:lnTo>
+                    <a:pt x="3047" y="0"/>
+                  </a:lnTo>
+                  <a:close/>
+                </a:path>
+              </a:pathLst>
+            </a:custGeom>
+            <a:solidFill>
+              <a:srgbClr val="E2E2E2"/>
+            </a:solidFill>
+          </p:spPr>
+          <p:txBody>
+            <a:bodyPr wrap="square" lIns="0" tIns="0" rIns="0" bIns="0" rtlCol="0"/>
+            <a:lstStyle/>
+            <a:p>
+              <a:endParaRPr/>
+            </a:p>
+          </p:txBody>
+        </p:sp>
+        <p:sp>
+          <p:nvSpPr>
+            <p:cNvPr id="42" name="object 42">
+              <a:extLst>
+                <a:ext uri="{FF2B5EF4-FFF2-40B4-BE49-F238E27FC236}">
+                  <a16:creationId xmlns:a16="http://schemas.microsoft.com/office/drawing/2014/main" id="{5D0ECD1B-5AC3-D267-7DC9-BD038839AA29}"/>
+                </a:ext>
+              </a:extLst>
+            </p:cNvPr>
+            <p:cNvSpPr/>
+            <p:nvPr/>
+          </p:nvSpPr>
+          <p:spPr>
+            <a:xfrm>
+              <a:off x="801928" y="7829676"/>
+              <a:ext cx="3175" cy="3175"/>
+            </a:xfrm>
+            <a:custGeom>
+              <a:avLst/>
+              <a:gdLst/>
+              <a:ahLst/>
+              <a:cxnLst/>
+              <a:rect l="l" t="t" r="r" b="b"/>
+              <a:pathLst>
+                <a:path w="3175" h="3175">
+                  <a:moveTo>
+                    <a:pt x="3048" y="0"/>
+                  </a:moveTo>
+                  <a:lnTo>
+                    <a:pt x="0" y="0"/>
+                  </a:lnTo>
+                  <a:lnTo>
+                    <a:pt x="0" y="3047"/>
+                  </a:lnTo>
+                  <a:lnTo>
+                    <a:pt x="3048" y="3047"/>
+                  </a:lnTo>
+                  <a:lnTo>
+                    <a:pt x="3048" y="0"/>
+                  </a:lnTo>
+                  <a:close/>
+                </a:path>
+              </a:pathLst>
+            </a:custGeom>
+            <a:solidFill>
+              <a:srgbClr val="9F9F9F"/>
+            </a:solidFill>
+          </p:spPr>
+          <p:txBody>
+            <a:bodyPr wrap="square" lIns="0" tIns="0" rIns="0" bIns="0" rtlCol="0"/>
+            <a:lstStyle/>
+            <a:p>
+              <a:endParaRPr/>
+            </a:p>
+          </p:txBody>
+        </p:sp>
+        <p:sp>
+          <p:nvSpPr>
+            <p:cNvPr id="43" name="object 43">
+              <a:extLst>
+                <a:ext uri="{FF2B5EF4-FFF2-40B4-BE49-F238E27FC236}">
+                  <a16:creationId xmlns:a16="http://schemas.microsoft.com/office/drawing/2014/main" id="{E1F203BE-9F4F-409A-B60D-281EDA850CCE}"/>
+                </a:ext>
+              </a:extLst>
+            </p:cNvPr>
+            <p:cNvSpPr/>
+            <p:nvPr/>
+          </p:nvSpPr>
+          <p:spPr>
+            <a:xfrm>
+              <a:off x="801928" y="7829689"/>
+              <a:ext cx="6402070" cy="3175"/>
+            </a:xfrm>
+            <a:custGeom>
+              <a:avLst/>
+              <a:gdLst/>
+              <a:ahLst/>
+              <a:cxnLst/>
+              <a:rect l="l" t="t" r="r" b="b"/>
+              <a:pathLst>
+                <a:path w="6402070" h="3175">
+                  <a:moveTo>
+                    <a:pt x="6402006" y="0"/>
+                  </a:moveTo>
+                  <a:lnTo>
+                    <a:pt x="6399022" y="0"/>
+                  </a:lnTo>
+                  <a:lnTo>
+                    <a:pt x="3048" y="0"/>
+                  </a:lnTo>
+                  <a:lnTo>
+                    <a:pt x="0" y="0"/>
+                  </a:lnTo>
+                  <a:lnTo>
+                    <a:pt x="0" y="3035"/>
+                  </a:lnTo>
+                  <a:lnTo>
+                    <a:pt x="3048" y="3035"/>
+                  </a:lnTo>
+                  <a:lnTo>
+                    <a:pt x="6398971" y="3035"/>
+                  </a:lnTo>
+                  <a:lnTo>
+                    <a:pt x="6402006" y="3035"/>
+                  </a:lnTo>
+                  <a:lnTo>
+                    <a:pt x="6402006" y="0"/>
+                  </a:lnTo>
+                  <a:close/>
+                </a:path>
+              </a:pathLst>
+            </a:custGeom>
+            <a:solidFill>
+              <a:srgbClr val="E2E2E2"/>
+            </a:solidFill>
+          </p:spPr>
+          <p:txBody>
+            <a:bodyPr wrap="square" lIns="0" tIns="0" rIns="0" bIns="0" rtlCol="0"/>
+            <a:lstStyle/>
+            <a:p>
+              <a:endParaRPr/>
+            </a:p>
+          </p:txBody>
+        </p:sp>
+      </p:grpSp>
+      <p:sp>
+        <p:nvSpPr>
+          <p:cNvPr id="44" name="object 44">
+            <a:extLst>
+              <a:ext uri="{FF2B5EF4-FFF2-40B4-BE49-F238E27FC236}">
+                <a16:creationId xmlns:a16="http://schemas.microsoft.com/office/drawing/2014/main" id="{009EBF4E-06F3-B7F0-D41E-0591EE2EB9F1}"/>
+              </a:ext>
+            </a:extLst>
+          </p:cNvPr>
+          <p:cNvSpPr txBox="1"/>
+          <p:nvPr/>
+        </p:nvSpPr>
+        <p:spPr>
+          <a:xfrm>
+            <a:off x="734047" y="8921270"/>
+            <a:ext cx="6414135" cy="1100301"/>
+          </a:xfrm>
+          <a:prstGeom prst="rect">
+            <a:avLst/>
+          </a:prstGeom>
+        </p:spPr>
+        <p:txBody>
+          <a:bodyPr vert="horz" wrap="square" lIns="0" tIns="12700" rIns="0" bIns="0" rtlCol="0">
+            <a:spAutoFit/>
+          </a:bodyPr>
+          <a:lstStyle/>
+          <a:p>
+            <a:pPr marL="12700">
+              <a:lnSpc>
+                <a:spcPct val="100000"/>
+              </a:lnSpc>
+              <a:spcBef>
+                <a:spcPts val="100"/>
+              </a:spcBef>
+            </a:pPr>
+            <a:r>
+              <a:rPr sz="1400" b="1" dirty="0">
+                <a:solidFill>
+                  <a:srgbClr val="3B78D7"/>
+                </a:solidFill>
+                <a:latin typeface="Times New Roman"/>
+                <a:cs typeface="Times New Roman"/>
+              </a:rPr>
+              <a:t>8.</a:t>
+            </a:r>
+            <a:r>
+              <a:rPr sz="1400" b="1" spc="-5" dirty="0">
+                <a:solidFill>
+                  <a:srgbClr val="3B78D7"/>
+                </a:solidFill>
+                <a:latin typeface="Times New Roman"/>
+                <a:cs typeface="Times New Roman"/>
+              </a:rPr>
+              <a:t> </a:t>
+            </a:r>
+            <a:r>
+              <a:rPr sz="1400" b="1" spc="-10" dirty="0">
+                <a:solidFill>
+                  <a:srgbClr val="3B78D7"/>
+                </a:solidFill>
+                <a:latin typeface="Times New Roman"/>
+                <a:cs typeface="Times New Roman"/>
+              </a:rPr>
+              <a:t>Conclusion:</a:t>
+            </a:r>
+            <a:endParaRPr sz="1400" dirty="0">
+              <a:latin typeface="Times New Roman"/>
+              <a:cs typeface="Times New Roman"/>
+            </a:endParaRPr>
+          </a:p>
+          <a:p>
+            <a:pPr marL="106680" marR="5080">
+              <a:lnSpc>
+                <a:spcPts val="1380"/>
+              </a:lnSpc>
+              <a:spcBef>
+                <a:spcPts val="1235"/>
+              </a:spcBef>
+            </a:pPr>
+            <a:r>
+              <a:rPr lang="en-US" sz="1300" dirty="0">
+                <a:latin typeface="Times New Roman"/>
+                <a:cs typeface="Times New Roman"/>
+              </a:rPr>
+              <a:t>The project successfully integrates HTML, CSS, and JavaScript to form a complete registration system. The validation logic ensures data quality, while the dynamic table update provides immediate satisfaction to the user, proving that client-side scripting is essential for a modern web experience.</a:t>
+            </a:r>
+            <a:endParaRPr sz="1300" dirty="0">
+              <a:latin typeface="Times New Roman"/>
+              <a:cs typeface="Times New Roman"/>
+            </a:endParaRPr>
+          </a:p>
+        </p:txBody>
+      </p:sp>
+      <p:pic>
+        <p:nvPicPr>
+          <p:cNvPr id="45" name="object 45">
+            <a:extLst>
+              <a:ext uri="{FF2B5EF4-FFF2-40B4-BE49-F238E27FC236}">
+                <a16:creationId xmlns:a16="http://schemas.microsoft.com/office/drawing/2014/main" id="{4E14490B-BAB5-82C5-4733-185491BD7FFF}"/>
+              </a:ext>
+            </a:extLst>
+          </p:cNvPr>
+          <p:cNvPicPr/>
+          <p:nvPr/>
+        </p:nvPicPr>
+        <p:blipFill>
+          <a:blip r:embed="rId4" cstate="print"/>
+          <a:stretch>
+            <a:fillRect/>
+          </a:stretch>
+        </p:blipFill>
+        <p:spPr>
+          <a:xfrm>
+            <a:off x="2749550" y="577849"/>
+            <a:ext cx="1004798" cy="566420"/>
+          </a:xfrm>
+          <a:prstGeom prst="rect">
+            <a:avLst/>
+          </a:prstGeom>
+        </p:spPr>
+      </p:pic>
+      <p:pic>
+        <p:nvPicPr>
+          <p:cNvPr id="46" name="object 46">
+            <a:extLst>
+              <a:ext uri="{FF2B5EF4-FFF2-40B4-BE49-F238E27FC236}">
+                <a16:creationId xmlns:a16="http://schemas.microsoft.com/office/drawing/2014/main" id="{16E70FD3-1B3E-10B9-38C7-02E02D754392}"/>
+              </a:ext>
+            </a:extLst>
+          </p:cNvPr>
+          <p:cNvPicPr/>
+          <p:nvPr/>
+        </p:nvPicPr>
+        <p:blipFill>
+          <a:blip r:embed="rId5" cstate="print"/>
+          <a:stretch>
+            <a:fillRect/>
+          </a:stretch>
+        </p:blipFill>
+        <p:spPr>
+          <a:xfrm>
+            <a:off x="739775" y="615949"/>
+            <a:ext cx="1495933" cy="370204"/>
+          </a:xfrm>
+          <a:prstGeom prst="rect">
+            <a:avLst/>
+          </a:prstGeom>
+        </p:spPr>
+      </p:pic>
+      <p:pic>
+        <p:nvPicPr>
           <p:cNvPr id="5" name="Picture 4">
             <a:extLst>
               <a:ext uri="{FF2B5EF4-FFF2-40B4-BE49-F238E27FC236}">
-                <a16:creationId xmlns:a16="http://schemas.microsoft.com/office/drawing/2014/main" id="{3E183A41-7022-1A96-B9FC-B2F9FAF9457C}"/>
+                <a16:creationId xmlns:a16="http://schemas.microsoft.com/office/drawing/2014/main" id="{D662F9CA-F018-F1C9-26D5-0CAD3BECA16B}"/>
               </a:ext>
             </a:extLst>
           </p:cNvPr>
@@ -9866,7 +10159,7 @@
           <p:cNvPr id="7" name="Picture 6">
             <a:extLst>
               <a:ext uri="{FF2B5EF4-FFF2-40B4-BE49-F238E27FC236}">
-                <a16:creationId xmlns:a16="http://schemas.microsoft.com/office/drawing/2014/main" id="{8D5180CA-F9E0-B35A-6A06-E1F76EAF7461}"/>
+                <a16:creationId xmlns:a16="http://schemas.microsoft.com/office/drawing/2014/main" id="{8E7B0E5F-8DB7-6E25-B04A-0F290D1EA0E1}"/>
               </a:ext>
             </a:extLst>
           </p:cNvPr>
@@ -9902,7 +10195,7 @@
           <p:cNvPr id="9" name="TextBox 8">
             <a:extLst>
               <a:ext uri="{FF2B5EF4-FFF2-40B4-BE49-F238E27FC236}">
-                <a16:creationId xmlns:a16="http://schemas.microsoft.com/office/drawing/2014/main" id="{B4FFF8F5-F465-EEAD-94F2-DFE71FD159EF}"/>
+                <a16:creationId xmlns:a16="http://schemas.microsoft.com/office/drawing/2014/main" id="{5172B020-282A-C6C0-E08D-59F61CB35C37}"/>
               </a:ext>
             </a:extLst>
           </p:cNvPr>
@@ -9943,7 +10236,7 @@
           <p:cNvPr id="10" name="TextBox 9">
             <a:extLst>
               <a:ext uri="{FF2B5EF4-FFF2-40B4-BE49-F238E27FC236}">
-                <a16:creationId xmlns:a16="http://schemas.microsoft.com/office/drawing/2014/main" id="{B1C78DB6-42BB-7613-22CF-59752FF4090D}"/>
+                <a16:creationId xmlns:a16="http://schemas.microsoft.com/office/drawing/2014/main" id="{6A936738-DFD8-441E-C393-2CEEE3B2C783}"/>
               </a:ext>
             </a:extLst>
           </p:cNvPr>
@@ -9982,7 +10275,7 @@
     </p:spTree>
     <p:extLst>
       <p:ext uri="{BB962C8B-B14F-4D97-AF65-F5344CB8AC3E}">
-        <p14:creationId xmlns:p14="http://schemas.microsoft.com/office/powerpoint/2010/main" val="2896398324"/>
+        <p14:creationId xmlns:p14="http://schemas.microsoft.com/office/powerpoint/2010/main" val="2071083046"/>
       </p:ext>
     </p:extLst>
   </p:cSld>

</xml_diff>